<commit_message>
v.2 end of az os project
</commit_message>
<xml_diff>
--- a/آز سیستم عامل/ارائه.pptx
+++ b/آز سیستم عامل/ارائه.pptx
@@ -3343,6 +3343,9 @@
   <p:clrMapOvr>
     <a:masterClrMapping/>
   </p:clrMapOvr>
+  <p:transition spd="slow">
+    <p:push dir="u"/>
+  </p:transition>
 </p:sld>
 </file>
 
@@ -3459,6 +3462,9 @@
   <p:clrMapOvr>
     <a:masterClrMapping/>
   </p:clrMapOvr>
+  <p:transition spd="slow">
+    <p:push dir="u"/>
+  </p:transition>
 </p:sld>
 </file>
 
@@ -3536,6 +3542,9 @@
   <p:clrMapOvr>
     <a:masterClrMapping/>
   </p:clrMapOvr>
+  <p:transition spd="slow">
+    <p:push dir="u"/>
+  </p:transition>
 </p:sld>
 </file>
 
@@ -3596,6 +3605,9 @@
   <p:clrMapOvr>
     <a:masterClrMapping/>
   </p:clrMapOvr>
+  <p:transition spd="slow">
+    <p:push dir="u"/>
+  </p:transition>
 </p:sld>
 </file>
 
@@ -3662,6 +3674,9 @@
   <p:clrMapOvr>
     <a:masterClrMapping/>
   </p:clrMapOvr>
+  <p:transition spd="slow">
+    <p:push dir="u"/>
+  </p:transition>
 </p:sld>
 </file>
 
@@ -3739,6 +3754,9 @@
   <p:clrMapOvr>
     <a:masterClrMapping/>
   </p:clrMapOvr>
+  <p:transition spd="slow">
+    <p:push dir="u"/>
+  </p:transition>
 </p:sld>
 </file>
 
@@ -3840,6 +3858,9 @@
   <p:clrMapOvr>
     <a:masterClrMapping/>
   </p:clrMapOvr>
+  <p:transition spd="slow">
+    <p:push dir="u"/>
+  </p:transition>
 </p:sld>
 </file>
 
@@ -3941,6 +3962,9 @@
   <p:clrMapOvr>
     <a:masterClrMapping/>
   </p:clrMapOvr>
+  <p:transition spd="slow">
+    <p:push dir="u"/>
+  </p:transition>
 </p:sld>
 </file>
 

</xml_diff>